<commit_message>
audit: remove hard-coded IoU, serve segmenter by deployment check, re-measure U-Net, label CAN demo, fix zebra/depth/clock-dependent test, correct decks
</commit_message>
<xml_diff>
--- a/SIH2026_ROAD_SHIELD_Submission.pptx
+++ b/SIH2026_ROAD_SHIELD_Submission.pptx
@@ -6101,7 +6101,7 @@
                 </a:solidFill>
                 <a:latin typeface="Segoe UI"/>
               </a:rPr>
-              <a:t>11-stage edge pipeline analyzes pavement distress in 207ms and dispatches live GIS alerts.</a:t>
+              <a:t>11-stage pipeline analyzes a road photograph in ~2 s on CPU and issues sealed, geo-tagged work orders.</a:t>
             </a:r>
           </a:p>
           <a:p>
@@ -6176,7 +6176,7 @@
                 </a:solidFill>
                 <a:latin typeface="Segoe UI"/>
               </a:rPr>
-              <a:t>Automated 0–100 Pavement Condition Index regression with 99% correlation to manual civil engineering surveys.</a:t>
+              <a:t>Standard 0–100 Pavement Condition Index by the ASTM D6433 deduct-value procedure; field validation planned in the pilot.</a:t>
             </a:r>
           </a:p>
           <a:p>
@@ -6373,7 +6373,7 @@
                 </a:solidFill>
                 <a:latin typeface="Segoe UI"/>
               </a:rPr>
-              <a:t>• Pure NumPy Edge AI: </a:t>
+              <a:t>• CPU-Only Edge AI: </a:t>
             </a:r>
             <a:r>
               <a:rPr sz="1000" b="0">
@@ -6382,7 +6382,7 @@
                 </a:solidFill>
                 <a:latin typeface="Segoe UI"/>
               </a:rPr>
-              <a:t>Custom Transformer-CNN runs in 207ms on standard ARM CPUs—zero heavy GPU or cloud inference required.</a:t>
+              <a:t>Fine-tuned CNNs on ONNX Runtime run on standard CPUs—classifier ~5 ms per frame, no GPU or cloud inference required.</a:t>
             </a:r>
           </a:p>
           <a:p>
@@ -6410,7 +6410,7 @@
                 </a:solidFill>
                 <a:latin typeface="Segoe UI"/>
               </a:rPr>
-              <a:t>Camera and accelerometer cross-validate distress, eliminating 94% of false positives from shadows and puddles.</a:t>
+              <a:t>Camera and 100 Hz accelerometer evidence are combined in one Bayesian gate; false-positive reduction to be measured on bus data in the pilot.</a:t>
             </a:r>
           </a:p>
           <a:p>
@@ -6820,7 +6820,7 @@
                 </a:solidFill>
                 <a:latin typeface="Segoe UI"/>
               </a:rPr>
-              <a:t>Python 3.10, Pure NumPy custom matrix forward/backward passes (zero PyTorch/TF dependency at edge).</a:t>
+              <a:t>Python, ONNX Runtime on CPU (no GPU, no PyTorch/TF at inference); CNNs fine-tuned on a Colab T4 GPU.</a:t>
             </a:r>
           </a:p>
           <a:p>
@@ -6979,7 +6979,7 @@
                 </a:solidFill>
                 <a:latin typeface="Segoe UI"/>
               </a:rPr>
-              <a:t>[1] Optical Decode → [2] Texture Gatekeeper (Std ≥ 6.5) → [3] Cavity BBox Extraction → [4] VisionDistressNet 9-Class Classifier (79.87% acc) → [5] IPM Homography (Metric Area) → [6] 100Hz IMU Shock Analysis → [7] Bayesian Sensor Fusion → [8] ASTM D6433 PCI Regressor (MAE: 1.42) → [9] 180-Day Deterioration Forecast → [10] MoRTH Civil BOQ Generator → [11] SHA-256 Cryptographic Dispatch.</a:t>
+              <a:t>[1] Optical Decode → [2] Texture Gatekeeper (Std ≥ 6.5) → [3] Cavity BBox Extraction → [4] Road-Condition CNN, 7 classes (94.9% held-out acc) → [5] IPM Homography (Metric Area) → [6] 100Hz IMU Shock Analysis → [7] Bayesian Sensor Fusion → [8] ASTM D6433 PCI (deduct-value procedure) → [9] 180-Day Deterioration Forecast → [10] MoRTH Civil BOQ Generator → [11] SHA-256 Cryptographic Dispatch.</a:t>
             </a:r>
           </a:p>
           <a:p>
@@ -6998,7 +6998,7 @@
                 </a:solidFill>
                 <a:latin typeface="Segoe UI"/>
               </a:rPr>
-              <a:t>• Working Prototype Verification (10/10 Tests Passed): </a:t>
+              <a:t>• Working Prototype Verification (356 Tests Passed): </a:t>
             </a:r>
             <a:r>
               <a:rPr sz="1000" b="0">
@@ -7063,7 +7063,7 @@
                 </a:solidFill>
                 <a:latin typeface="Segoe UI"/>
               </a:rPr>
-              <a:t>Average latency: 207ms/frame on CPU; PCI accuracy: R² = 0.99, MAE = 1.42 points; Memory footprint: &lt;180MB.</a:t>
+              <a:t>Classifier ~5 ms/frame, full photo analysis ~2 s on CPU; 94.9% accuracy (92.3% on Indian roads); IMU classifier 86.6%.</a:t>
             </a:r>
           </a:p>
           <a:p>
@@ -7091,7 +7091,7 @@
                 </a:solidFill>
                 <a:latin typeface="Segoe UI"/>
               </a:rPr>
-              <a:t>Public repository: github.com/udbhav968-creator/SIH_PROJECT (12 commits, production-ready code).</a:t>
+              <a:t>Public repository: github.com/udbhav968-creator/SIH_PROJECT (356 automated tests pass).</a:t>
             </a:r>
           </a:p>
         </p:txBody>
@@ -7480,7 +7480,7 @@
                 </a:solidFill>
                 <a:latin typeface="Segoe UI"/>
               </a:rPr>
-              <a:t>10/10 automated tests passing; lightweight NumPy models execute in 207ms on low-cost ARM CPUs without GPU.</a:t>
+              <a:t>356 automated tests passing; every model runs on ONNX Runtime on an ordinary CPU without a GPU.</a:t>
             </a:r>
           </a:p>
           <a:p>
@@ -9233,7 +9233,7 @@
                 </a:solidFill>
                 <a:latin typeface="Segoe UI"/>
               </a:rPr>
-              <a:t>github.com/udbhav968-creator/SIH_PROJECT (10/10 automated tests PASS, 12 commits, production-ready code).</a:t>
+              <a:t>github.com/udbhav968-creator/SIH_PROJECT (356 automated tests pass).</a:t>
             </a:r>
           </a:p>
         </p:txBody>

</xml_diff>

<commit_message>
restore documented classifier weights; measured zebra veto in both engines; re-record samples; update decks and docs
</commit_message>
<xml_diff>
--- a/SIH2026_ROAD_SHIELD_Submission.pptx
+++ b/SIH2026_ROAD_SHIELD_Submission.pptx
@@ -6979,7 +6979,7 @@
                 </a:solidFill>
                 <a:latin typeface="Segoe UI"/>
               </a:rPr>
-              <a:t>[1] Optical Decode → [2] Texture Gatekeeper (Std ≥ 6.5) → [3] Cavity BBox Extraction → [4] Road-Condition CNN, 7 classes (94.9% held-out acc) → [5] IPM Homography (Metric Area) → [6] 100Hz IMU Shock Analysis → [7] Bayesian Sensor Fusion → [8] ASTM D6433 PCI (deduct-value procedure) → [9] 180-Day Deterioration Forecast → [10] MoRTH Civil BOQ Generator → [11] SHA-256 Cryptographic Dispatch.</a:t>
+              <a:t>[1] Optical Decode → [2] Texture Gatekeeper (Std ≥ 6.5) → [3] Cavity BBox Extraction → [4] Road-Condition CNN, 7 classes (94.4% held-out acc) → [5] IPM Homography (Metric Area) → [6] 100Hz IMU Shock Analysis → [7] Bayesian Sensor Fusion → [8] ASTM D6433 PCI (deduct-value procedure) → [9] 180-Day Deterioration Forecast → [10] MoRTH Civil BOQ Generator → [11] SHA-256 Cryptographic Dispatch.</a:t>
             </a:r>
           </a:p>
           <a:p>
@@ -7063,7 +7063,7 @@
                 </a:solidFill>
                 <a:latin typeface="Segoe UI"/>
               </a:rPr>
-              <a:t>Classifier ~5 ms/frame, full photo analysis ~2 s on CPU; 94.9% accuracy (92.3% on Indian roads); IMU classifier 86.6%.</a:t>
+              <a:t>Classifier ~5 ms/frame, full photo analysis ~2 s on CPU; 94.4% accuracy (92.3% on Indian roads); IMU classifier 86.6%.</a:t>
             </a:r>
           </a:p>
           <a:p>

</xml_diff>